<commit_message>
docs: update author information and slide presentation content
</commit_message>
<xml_diff>
--- a/bluestock_mf_capstone/reports/Presentation.pptx
+++ b/bluestock_mf_capstone/reports/Presentation.pptx
@@ -3339,7 +3339,7 @@
                 </a:solidFill>
                 <a:latin typeface="Calibri"/>
               </a:rPr>
-              <a:t>👥 Team: Sai Sindhuja Ch · Sarvesh K Yadav · Ganga Damalathi</a:t>
+              <a:t>👥 Sarvesh Kumar Yadav</a:t>
             </a:r>
           </a:p>
         </p:txBody>
@@ -9152,7 +9152,7 @@
                 </a:solidFill>
                 <a:latin typeface="Calibri"/>
               </a:rPr>
-              <a:t>Sai Sindhuja Ch · Sarvesh K Yadav · Ganga Damalathi</a:t>
+              <a:t>Sarvesh Kumar Yadav</a:t>
             </a:r>
           </a:p>
         </p:txBody>

</xml_diff>